<commit_message>
Resources for final submission made
Images added for team website and final pitch is done.
</commit_message>
<xml_diff>
--- a/Documentation/Final pitch.pptx
+++ b/Documentation/Final pitch.pptx
@@ -318,7 +318,7 @@
           <a:p>
             <a:fld id="{F1058B0F-123C-48DF-B2B9-806A9A5212CF}" type="datetimeFigureOut">
               <a:rPr lang="en-GB" smtClean="0"/>
-              <a:t>20/04/2026</a:t>
+              <a:t>25/04/2026</a:t>
             </a:fld>
             <a:endParaRPr lang="en-GB"/>
           </a:p>
@@ -599,7 +599,7 @@
           <a:p>
             <a:fld id="{F1058B0F-123C-48DF-B2B9-806A9A5212CF}" type="datetimeFigureOut">
               <a:rPr lang="en-GB" smtClean="0"/>
-              <a:t>20/04/2026</a:t>
+              <a:t>25/04/2026</a:t>
             </a:fld>
             <a:endParaRPr lang="en-GB"/>
           </a:p>
@@ -791,7 +791,7 @@
           <a:p>
             <a:fld id="{F1058B0F-123C-48DF-B2B9-806A9A5212CF}" type="datetimeFigureOut">
               <a:rPr lang="en-GB" smtClean="0"/>
-              <a:t>20/04/2026</a:t>
+              <a:t>25/04/2026</a:t>
             </a:fld>
             <a:endParaRPr lang="en-GB"/>
           </a:p>
@@ -1052,7 +1052,7 @@
           <a:p>
             <a:fld id="{F1058B0F-123C-48DF-B2B9-806A9A5212CF}" type="datetimeFigureOut">
               <a:rPr lang="en-GB" smtClean="0"/>
-              <a:t>20/04/2026</a:t>
+              <a:t>25/04/2026</a:t>
             </a:fld>
             <a:endParaRPr lang="en-GB"/>
           </a:p>
@@ -1478,7 +1478,7 @@
           <a:p>
             <a:fld id="{F1058B0F-123C-48DF-B2B9-806A9A5212CF}" type="datetimeFigureOut">
               <a:rPr lang="en-GB" smtClean="0"/>
-              <a:t>20/04/2026</a:t>
+              <a:t>25/04/2026</a:t>
             </a:fld>
             <a:endParaRPr lang="en-GB"/>
           </a:p>
@@ -2024,7 +2024,7 @@
           <a:p>
             <a:fld id="{F1058B0F-123C-48DF-B2B9-806A9A5212CF}" type="datetimeFigureOut">
               <a:rPr lang="en-GB" smtClean="0"/>
-              <a:t>20/04/2026</a:t>
+              <a:t>25/04/2026</a:t>
             </a:fld>
             <a:endParaRPr lang="en-GB"/>
           </a:p>
@@ -2855,7 +2855,7 @@
           <a:p>
             <a:fld id="{F1058B0F-123C-48DF-B2B9-806A9A5212CF}" type="datetimeFigureOut">
               <a:rPr lang="en-GB" smtClean="0"/>
-              <a:t>20/04/2026</a:t>
+              <a:t>25/04/2026</a:t>
             </a:fld>
             <a:endParaRPr lang="en-GB"/>
           </a:p>
@@ -3025,7 +3025,7 @@
           <a:p>
             <a:fld id="{F1058B0F-123C-48DF-B2B9-806A9A5212CF}" type="datetimeFigureOut">
               <a:rPr lang="en-GB" smtClean="0"/>
-              <a:t>20/04/2026</a:t>
+              <a:t>25/04/2026</a:t>
             </a:fld>
             <a:endParaRPr lang="en-GB"/>
           </a:p>
@@ -3205,7 +3205,7 @@
           <a:p>
             <a:fld id="{F1058B0F-123C-48DF-B2B9-806A9A5212CF}" type="datetimeFigureOut">
               <a:rPr lang="en-GB" smtClean="0"/>
-              <a:t>20/04/2026</a:t>
+              <a:t>25/04/2026</a:t>
             </a:fld>
             <a:endParaRPr lang="en-GB"/>
           </a:p>
@@ -3375,7 +3375,7 @@
           <a:p>
             <a:fld id="{F1058B0F-123C-48DF-B2B9-806A9A5212CF}" type="datetimeFigureOut">
               <a:rPr lang="en-GB" smtClean="0"/>
-              <a:t>20/04/2026</a:t>
+              <a:t>25/04/2026</a:t>
             </a:fld>
             <a:endParaRPr lang="en-GB"/>
           </a:p>
@@ -3632,7 +3632,7 @@
           <a:p>
             <a:fld id="{F1058B0F-123C-48DF-B2B9-806A9A5212CF}" type="datetimeFigureOut">
               <a:rPr lang="en-GB" smtClean="0"/>
-              <a:t>20/04/2026</a:t>
+              <a:t>25/04/2026</a:t>
             </a:fld>
             <a:endParaRPr lang="en-GB"/>
           </a:p>
@@ -3864,7 +3864,7 @@
           <a:p>
             <a:fld id="{F1058B0F-123C-48DF-B2B9-806A9A5212CF}" type="datetimeFigureOut">
               <a:rPr lang="en-GB" smtClean="0"/>
-              <a:t>20/04/2026</a:t>
+              <a:t>25/04/2026</a:t>
             </a:fld>
             <a:endParaRPr lang="en-GB"/>
           </a:p>
@@ -4257,7 +4257,7 @@
           <a:p>
             <a:fld id="{F1058B0F-123C-48DF-B2B9-806A9A5212CF}" type="datetimeFigureOut">
               <a:rPr lang="en-GB" smtClean="0"/>
-              <a:t>20/04/2026</a:t>
+              <a:t>25/04/2026</a:t>
             </a:fld>
             <a:endParaRPr lang="en-GB"/>
           </a:p>
@@ -4375,7 +4375,7 @@
           <a:p>
             <a:fld id="{F1058B0F-123C-48DF-B2B9-806A9A5212CF}" type="datetimeFigureOut">
               <a:rPr lang="en-GB" smtClean="0"/>
-              <a:t>20/04/2026</a:t>
+              <a:t>25/04/2026</a:t>
             </a:fld>
             <a:endParaRPr lang="en-GB"/>
           </a:p>
@@ -4470,7 +4470,7 @@
           <a:p>
             <a:fld id="{F1058B0F-123C-48DF-B2B9-806A9A5212CF}" type="datetimeFigureOut">
               <a:rPr lang="en-GB" smtClean="0"/>
-              <a:t>20/04/2026</a:t>
+              <a:t>25/04/2026</a:t>
             </a:fld>
             <a:endParaRPr lang="en-GB"/>
           </a:p>
@@ -4743,7 +4743,7 @@
           <a:p>
             <a:fld id="{F1058B0F-123C-48DF-B2B9-806A9A5212CF}" type="datetimeFigureOut">
               <a:rPr lang="en-GB" smtClean="0"/>
-              <a:t>20/04/2026</a:t>
+              <a:t>25/04/2026</a:t>
             </a:fld>
             <a:endParaRPr lang="en-GB"/>
           </a:p>
@@ -5024,7 +5024,7 @@
           <a:p>
             <a:fld id="{F1058B0F-123C-48DF-B2B9-806A9A5212CF}" type="datetimeFigureOut">
               <a:rPr lang="en-GB" smtClean="0"/>
-              <a:t>20/04/2026</a:t>
+              <a:t>25/04/2026</a:t>
             </a:fld>
             <a:endParaRPr lang="en-GB"/>
           </a:p>
@@ -5264,7 +5264,7 @@
           <a:p>
             <a:fld id="{F1058B0F-123C-48DF-B2B9-806A9A5212CF}" type="datetimeFigureOut">
               <a:rPr lang="en-GB" smtClean="0"/>
-              <a:t>20/04/2026</a:t>
+              <a:t>25/04/2026</a:t>
             </a:fld>
             <a:endParaRPr lang="en-GB"/>
           </a:p>
@@ -8999,15 +8999,123 @@
         </p:nvPicPr>
         <p:blipFill>
           <a:blip r:embed="rId3"/>
-          <a:srcRect l="16493" t="9025" r="31453" b="36883"/>
+          <a:srcRect l="24833" t="12037" r="64108" b="71138"/>
           <a:stretch>
             <a:fillRect/>
           </a:stretch>
         </p:blipFill>
         <p:spPr>
           <a:xfrm>
-            <a:off x="4913376" y="1245906"/>
-            <a:ext cx="6886396" cy="3900026"/>
+            <a:off x="8356752" y="26066"/>
+            <a:ext cx="2033720" cy="1686293"/>
+          </a:xfrm>
+          <a:prstGeom prst="rect">
+            <a:avLst/>
+          </a:prstGeom>
+        </p:spPr>
+      </p:pic>
+      <p:pic>
+        <p:nvPicPr>
+          <p:cNvPr id="4" name="Picture 3">
+            <a:extLst>
+              <a:ext uri="{FF2B5EF4-FFF2-40B4-BE49-F238E27FC236}">
+                <a16:creationId xmlns:a16="http://schemas.microsoft.com/office/drawing/2014/main" id="{B1C5AD52-31D4-1D31-9D91-9D5800024827}"/>
+              </a:ext>
+            </a:extLst>
+          </p:cNvPr>
+          <p:cNvPicPr>
+            <a:picLocks noChangeAspect="1"/>
+          </p:cNvPicPr>
+          <p:nvPr/>
+        </p:nvPicPr>
+        <p:blipFill>
+          <a:blip r:embed="rId4">
+            <a:extLst>
+              <a:ext uri="{28A0092B-C50C-407E-A947-70E740481C1C}">
+                <a14:useLocalDpi xmlns:a14="http://schemas.microsoft.com/office/drawing/2010/main" val="0"/>
+              </a:ext>
+            </a:extLst>
+          </a:blip>
+          <a:stretch>
+            <a:fillRect/>
+          </a:stretch>
+        </p:blipFill>
+        <p:spPr>
+          <a:xfrm>
+            <a:off x="256032" y="198286"/>
+            <a:ext cx="4670246" cy="2624161"/>
+          </a:xfrm>
+          <a:prstGeom prst="rect">
+            <a:avLst/>
+          </a:prstGeom>
+        </p:spPr>
+      </p:pic>
+      <p:pic>
+        <p:nvPicPr>
+          <p:cNvPr id="6" name="Picture 5">
+            <a:extLst>
+              <a:ext uri="{FF2B5EF4-FFF2-40B4-BE49-F238E27FC236}">
+                <a16:creationId xmlns:a16="http://schemas.microsoft.com/office/drawing/2014/main" id="{6F6BF4B7-7C83-AF1B-4E69-598F3944B859}"/>
+              </a:ext>
+            </a:extLst>
+          </p:cNvPr>
+          <p:cNvPicPr>
+            <a:picLocks noChangeAspect="1"/>
+          </p:cNvPicPr>
+          <p:nvPr/>
+        </p:nvPicPr>
+        <p:blipFill>
+          <a:blip r:embed="rId5">
+            <a:extLst>
+              <a:ext uri="{28A0092B-C50C-407E-A947-70E740481C1C}">
+                <a14:useLocalDpi xmlns:a14="http://schemas.microsoft.com/office/drawing/2010/main" val="0"/>
+              </a:ext>
+            </a:extLst>
+          </a:blip>
+          <a:stretch>
+            <a:fillRect/>
+          </a:stretch>
+        </p:blipFill>
+        <p:spPr>
+          <a:xfrm>
+            <a:off x="4910414" y="1737360"/>
+            <a:ext cx="6276956" cy="3521386"/>
+          </a:xfrm>
+          <a:prstGeom prst="rect">
+            <a:avLst/>
+          </a:prstGeom>
+        </p:spPr>
+      </p:pic>
+      <p:pic>
+        <p:nvPicPr>
+          <p:cNvPr id="9" name="Picture 8">
+            <a:extLst>
+              <a:ext uri="{FF2B5EF4-FFF2-40B4-BE49-F238E27FC236}">
+                <a16:creationId xmlns:a16="http://schemas.microsoft.com/office/drawing/2014/main" id="{B9A07B58-7E9F-BC7A-22DB-E3F91BBE93AF}"/>
+              </a:ext>
+            </a:extLst>
+          </p:cNvPr>
+          <p:cNvPicPr>
+            <a:picLocks noChangeAspect="1"/>
+          </p:cNvPicPr>
+          <p:nvPr/>
+        </p:nvPicPr>
+        <p:blipFill>
+          <a:blip r:embed="rId6">
+            <a:extLst>
+              <a:ext uri="{28A0092B-C50C-407E-A947-70E740481C1C}">
+                <a14:useLocalDpi xmlns:a14="http://schemas.microsoft.com/office/drawing/2010/main" val="0"/>
+              </a:ext>
+            </a:extLst>
+          </a:blip>
+          <a:stretch>
+            <a:fillRect/>
+          </a:stretch>
+        </p:blipFill>
+        <p:spPr>
+          <a:xfrm>
+            <a:off x="159792" y="3787831"/>
+            <a:ext cx="5314416" cy="2981610"/>
           </a:xfrm>
           <a:prstGeom prst="rect">
             <a:avLst/>

</xml_diff>